<commit_message>
Docs: Update Continuous Access Reconciliation presentation
Signed-off-by: Omer Boehm <omerboehm@gmail.com>

Assisted-By: Claude (Anthropic AI) <noreply@anthropic.com>
</commit_message>
<xml_diff>
--- a/aiac/docs/presentations/AIAC-Continuous-Access-Reconciliation.pptx
+++ b/aiac/docs/presentations/AIAC-Continuous-Access-Reconciliation.pptx
@@ -234,7 +234,7 @@
           <a:p>
             <a:fld id="{3CFE4C92-B03D-6F47-8527-F4C20724E937}" type="datetimeFigureOut">
               <a:rPr lang="en-IL" smtClean="0"/>
-              <a:t>17/08/2026</a:t>
+              <a:t>18/08/2026</a:t>
             </a:fld>
             <a:endParaRPr lang="en-IL"/>
           </a:p>
@@ -1344,7 +1344,7 @@
           <a:p>
             <a:fld id="{5BCAD085-E8A6-8845-BD4E-CB4CCA059FC4}" type="datetimeFigureOut">
               <a:rPr lang="en-US" smtClean="0"/>
-              <a:t>8/17/26</a:t>
+              <a:t>8/18/26</a:t>
             </a:fld>
             <a:endParaRPr lang="en-US"/>
           </a:p>
@@ -1512,7 +1512,7 @@
           <a:p>
             <a:fld id="{5BCAD085-E8A6-8845-BD4E-CB4CCA059FC4}" type="datetimeFigureOut">
               <a:rPr lang="en-US" smtClean="0"/>
-              <a:t>8/17/26</a:t>
+              <a:t>8/18/26</a:t>
             </a:fld>
             <a:endParaRPr lang="en-US"/>
           </a:p>
@@ -1690,7 +1690,7 @@
           <a:p>
             <a:fld id="{5BCAD085-E8A6-8845-BD4E-CB4CCA059FC4}" type="datetimeFigureOut">
               <a:rPr lang="en-US" smtClean="0"/>
-              <a:t>8/17/26</a:t>
+              <a:t>8/18/26</a:t>
             </a:fld>
             <a:endParaRPr lang="en-US"/>
           </a:p>
@@ -1893,7 +1893,7 @@
           <a:p>
             <a:fld id="{5BCAD085-E8A6-8845-BD4E-CB4CCA059FC4}" type="datetimeFigureOut">
               <a:rPr lang="en-US" smtClean="0"/>
-              <a:t>8/17/26</a:t>
+              <a:t>8/18/26</a:t>
             </a:fld>
             <a:endParaRPr lang="en-US"/>
           </a:p>
@@ -2138,7 +2138,7 @@
           <a:p>
             <a:fld id="{5BCAD085-E8A6-8845-BD4E-CB4CCA059FC4}" type="datetimeFigureOut">
               <a:rPr lang="en-US" smtClean="0"/>
-              <a:t>8/17/26</a:t>
+              <a:t>8/18/26</a:t>
             </a:fld>
             <a:endParaRPr lang="en-US"/>
           </a:p>
@@ -2423,7 +2423,7 @@
           <a:p>
             <a:fld id="{5BCAD085-E8A6-8845-BD4E-CB4CCA059FC4}" type="datetimeFigureOut">
               <a:rPr lang="en-US" smtClean="0"/>
-              <a:t>8/17/26</a:t>
+              <a:t>8/18/26</a:t>
             </a:fld>
             <a:endParaRPr lang="en-US"/>
           </a:p>
@@ -2842,7 +2842,7 @@
           <a:p>
             <a:fld id="{5BCAD085-E8A6-8845-BD4E-CB4CCA059FC4}" type="datetimeFigureOut">
               <a:rPr lang="en-US" smtClean="0"/>
-              <a:t>8/17/26</a:t>
+              <a:t>8/18/26</a:t>
             </a:fld>
             <a:endParaRPr lang="en-US"/>
           </a:p>
@@ -2959,7 +2959,7 @@
           <a:p>
             <a:fld id="{5BCAD085-E8A6-8845-BD4E-CB4CCA059FC4}" type="datetimeFigureOut">
               <a:rPr lang="en-US" smtClean="0"/>
-              <a:t>8/17/26</a:t>
+              <a:t>8/18/26</a:t>
             </a:fld>
             <a:endParaRPr lang="en-US"/>
           </a:p>
@@ -3054,7 +3054,7 @@
           <a:p>
             <a:fld id="{5BCAD085-E8A6-8845-BD4E-CB4CCA059FC4}" type="datetimeFigureOut">
               <a:rPr lang="en-US" smtClean="0"/>
-              <a:t>8/17/26</a:t>
+              <a:t>8/18/26</a:t>
             </a:fld>
             <a:endParaRPr lang="en-US"/>
           </a:p>
@@ -3329,7 +3329,7 @@
           <a:p>
             <a:fld id="{5BCAD085-E8A6-8845-BD4E-CB4CCA059FC4}" type="datetimeFigureOut">
               <a:rPr lang="en-US" smtClean="0"/>
-              <a:t>8/17/26</a:t>
+              <a:t>8/18/26</a:t>
             </a:fld>
             <a:endParaRPr lang="en-US"/>
           </a:p>
@@ -3581,7 +3581,7 @@
           <a:p>
             <a:fld id="{5BCAD085-E8A6-8845-BD4E-CB4CCA059FC4}" type="datetimeFigureOut">
               <a:rPr lang="en-US" smtClean="0"/>
-              <a:t>8/17/26</a:t>
+              <a:t>8/18/26</a:t>
             </a:fld>
             <a:endParaRPr lang="en-US"/>
           </a:p>
@@ -3792,7 +3792,7 @@
           <a:p>
             <a:fld id="{5BCAD085-E8A6-8845-BD4E-CB4CCA059FC4}" type="datetimeFigureOut">
               <a:rPr lang="en-US" smtClean="0"/>
-              <a:t>8/17/26</a:t>
+              <a:t>8/18/26</a:t>
             </a:fld>
             <a:endParaRPr lang="en-US"/>
           </a:p>
@@ -20444,7 +20444,7 @@
         </p:nvSpPr>
         <p:spPr>
           <a:xfrm>
-            <a:off x="8526986" y="2517174"/>
+            <a:off x="7715456" y="1863228"/>
             <a:ext cx="822960" cy="457200"/>
           </a:xfrm>
           <a:prstGeom prst="roundRect">
@@ -20520,7 +20520,7 @@
         </p:nvSpPr>
         <p:spPr>
           <a:xfrm>
-            <a:off x="6606746" y="3477294"/>
+            <a:off x="6313240" y="3264784"/>
             <a:ext cx="1325880" cy="457200"/>
           </a:xfrm>
           <a:prstGeom prst="roundRect">
@@ -20590,7 +20590,7 @@
         </p:nvSpPr>
         <p:spPr>
           <a:xfrm>
-            <a:off x="8161226" y="3477294"/>
+            <a:off x="8193132" y="3329664"/>
             <a:ext cx="1234440" cy="457200"/>
           </a:xfrm>
           <a:prstGeom prst="roundRect">
@@ -20701,7 +20701,7 @@
         </p:nvSpPr>
         <p:spPr>
           <a:xfrm>
-            <a:off x="6698186" y="4437414"/>
+            <a:off x="6304799" y="4726974"/>
             <a:ext cx="1188720" cy="457200"/>
           </a:xfrm>
           <a:prstGeom prst="roundRect">
@@ -20771,7 +20771,7 @@
         </p:nvSpPr>
         <p:spPr>
           <a:xfrm>
-            <a:off x="8161226" y="4437414"/>
+            <a:off x="8390370" y="4853601"/>
             <a:ext cx="1188720" cy="457200"/>
           </a:xfrm>
           <a:prstGeom prst="roundRect">
@@ -20841,8 +20841,8 @@
         </p:nvSpPr>
         <p:spPr>
           <a:xfrm>
-            <a:off x="7237029" y="2543954"/>
-            <a:ext cx="1188720" cy="457200"/>
+            <a:off x="8995616" y="1911636"/>
+            <a:ext cx="651510" cy="276999"/>
           </a:xfrm>
           <a:prstGeom prst="rect">
             <a:avLst/>
@@ -20880,13 +20880,14 @@
           <p:cNvCxnSpPr>
             <a:cxnSpLocks/>
             <a:stCxn id="34" idx="2"/>
+            <a:endCxn id="35" idx="0"/>
           </p:cNvCxnSpPr>
           <p:nvPr/>
         </p:nvCxnSpPr>
         <p:spPr>
           <a:xfrm flipH="1">
-            <a:off x="7315406" y="2974374"/>
-            <a:ext cx="1623060" cy="502920"/>
+            <a:off x="6976180" y="2320428"/>
+            <a:ext cx="1150756" cy="944356"/>
           </a:xfrm>
           <a:prstGeom prst="line">
             <a:avLst/>
@@ -20921,13 +20922,17 @@
               </a:ext>
             </a:extLst>
           </p:cNvPr>
-          <p:cNvCxnSpPr/>
+          <p:cNvCxnSpPr>
+            <a:cxnSpLocks/>
+            <a:stCxn id="35" idx="2"/>
+            <a:endCxn id="38" idx="0"/>
+          </p:cNvCxnSpPr>
           <p:nvPr/>
         </p:nvCxnSpPr>
         <p:spPr>
           <a:xfrm flipH="1">
-            <a:off x="7292546" y="3934494"/>
-            <a:ext cx="22860" cy="502920"/>
+            <a:off x="6899159" y="3721984"/>
+            <a:ext cx="77021" cy="1004990"/>
           </a:xfrm>
           <a:prstGeom prst="line">
             <a:avLst/>
@@ -20967,7 +20972,7 @@
         </p:nvSpPr>
         <p:spPr>
           <a:xfrm>
-            <a:off x="6606746" y="4922046"/>
+            <a:off x="5965267" y="5310735"/>
             <a:ext cx="708660" cy="161583"/>
           </a:xfrm>
           <a:prstGeom prst="rect">
@@ -21006,13 +21011,14 @@
           <p:cNvCxnSpPr>
             <a:cxnSpLocks/>
             <a:stCxn id="34" idx="2"/>
+            <a:endCxn id="36" idx="0"/>
           </p:cNvCxnSpPr>
           <p:nvPr/>
         </p:nvCxnSpPr>
         <p:spPr>
-          <a:xfrm flipH="1">
-            <a:off x="8778446" y="2974374"/>
-            <a:ext cx="160020" cy="502920"/>
+          <a:xfrm>
+            <a:off x="8126936" y="2320428"/>
+            <a:ext cx="683416" cy="1009236"/>
           </a:xfrm>
           <a:prstGeom prst="line">
             <a:avLst/>
@@ -21052,8 +21058,8 @@
           <p:nvPr/>
         </p:nvSpPr>
         <p:spPr>
-          <a:xfrm>
-            <a:off x="7886906" y="4024371"/>
+          <a:xfrm rot="20726948">
+            <a:off x="7879640" y="4248414"/>
             <a:ext cx="708660" cy="161583"/>
           </a:xfrm>
           <a:prstGeom prst="rect">
@@ -21094,7 +21100,7 @@
         </p:nvSpPr>
         <p:spPr>
           <a:xfrm>
-            <a:off x="7584283" y="5481722"/>
+            <a:off x="7557613" y="5894628"/>
             <a:ext cx="3431177" cy="430887"/>
           </a:xfrm>
           <a:prstGeom prst="rect">
@@ -21156,7 +21162,7 @@
         </p:nvSpPr>
         <p:spPr>
           <a:xfrm>
-            <a:off x="9624266" y="2517174"/>
+            <a:off x="10104326" y="1863228"/>
             <a:ext cx="822960" cy="457200"/>
           </a:xfrm>
           <a:prstGeom prst="roundRect">
@@ -21236,8 +21242,8 @@
         </p:nvCxnSpPr>
         <p:spPr>
           <a:xfrm>
-            <a:off x="8938466" y="2974374"/>
-            <a:ext cx="1783080" cy="503281"/>
+            <a:off x="8126936" y="2320428"/>
+            <a:ext cx="2740816" cy="1001494"/>
           </a:xfrm>
           <a:prstGeom prst="line">
             <a:avLst/>
@@ -21278,7 +21284,7 @@
         </p:nvSpPr>
         <p:spPr>
           <a:xfrm>
-            <a:off x="10104326" y="3477655"/>
+            <a:off x="10250532" y="3321922"/>
             <a:ext cx="1234440" cy="457200"/>
           </a:xfrm>
           <a:prstGeom prst="roundRect">
@@ -21352,8 +21358,8 @@
         </p:nvCxnSpPr>
         <p:spPr>
           <a:xfrm>
-            <a:off x="10035746" y="2974374"/>
-            <a:ext cx="685800" cy="503281"/>
+            <a:off x="10515806" y="2320428"/>
+            <a:ext cx="351946" cy="1001494"/>
           </a:xfrm>
           <a:prstGeom prst="line">
             <a:avLst/>
@@ -21397,8 +21403,8 @@
         </p:nvCxnSpPr>
         <p:spPr>
           <a:xfrm flipH="1">
-            <a:off x="7269686" y="2974374"/>
-            <a:ext cx="2766060" cy="502920"/>
+            <a:off x="6976180" y="2320428"/>
+            <a:ext cx="3539626" cy="944356"/>
           </a:xfrm>
           <a:prstGeom prst="line">
             <a:avLst/>
@@ -21442,9 +21448,9 @@
           <p:nvPr/>
         </p:nvCxnSpPr>
         <p:spPr>
-          <a:xfrm flipH="1" flipV="1">
-            <a:off x="9395666" y="3705894"/>
-            <a:ext cx="708660" cy="361"/>
+          <a:xfrm flipH="1">
+            <a:off x="9427572" y="3550522"/>
+            <a:ext cx="822960" cy="7742"/>
           </a:xfrm>
           <a:prstGeom prst="line">
             <a:avLst/>
@@ -21487,9 +21493,9 @@
           <p:nvPr/>
         </p:nvCxnSpPr>
         <p:spPr>
-          <a:xfrm flipV="1">
-            <a:off x="8755586" y="3934494"/>
-            <a:ext cx="22860" cy="502920"/>
+          <a:xfrm flipH="1" flipV="1">
+            <a:off x="8810352" y="3786864"/>
+            <a:ext cx="174378" cy="1066737"/>
           </a:xfrm>
           <a:prstGeom prst="line">
             <a:avLst/>
@@ -21529,7 +21535,7 @@
         </p:nvSpPr>
         <p:spPr>
           <a:xfrm>
-            <a:off x="8669589" y="4244064"/>
+            <a:off x="8333220" y="4521128"/>
             <a:ext cx="708660" cy="161583"/>
           </a:xfrm>
           <a:prstGeom prst="rect">
@@ -21570,7 +21576,7 @@
         </p:nvSpPr>
         <p:spPr>
           <a:xfrm>
-            <a:off x="6693831" y="4094732"/>
+            <a:off x="6355287" y="4357507"/>
             <a:ext cx="708660" cy="161583"/>
           </a:xfrm>
           <a:prstGeom prst="rect">
@@ -21610,8 +21616,8 @@
           <p:nvPr/>
         </p:nvSpPr>
         <p:spPr>
-          <a:xfrm>
-            <a:off x="8264096" y="3266330"/>
+          <a:xfrm rot="20775577">
+            <a:off x="7683289" y="2802340"/>
             <a:ext cx="708660" cy="161583"/>
           </a:xfrm>
           <a:prstGeom prst="rect">
@@ -21652,7 +21658,7 @@
         </p:nvSpPr>
         <p:spPr>
           <a:xfrm>
-            <a:off x="9428323" y="3537384"/>
+            <a:off x="9461275" y="3570336"/>
             <a:ext cx="708660" cy="161583"/>
           </a:xfrm>
           <a:prstGeom prst="rect">
@@ -21697,8 +21703,8 @@
         </p:nvCxnSpPr>
         <p:spPr>
           <a:xfrm flipH="1">
-            <a:off x="9349946" y="3934855"/>
-            <a:ext cx="1371600" cy="731159"/>
+            <a:off x="9579090" y="3779122"/>
+            <a:ext cx="1288662" cy="1303079"/>
           </a:xfrm>
           <a:prstGeom prst="line">
             <a:avLst/>
@@ -21738,8 +21744,8 @@
           <p:nvPr/>
         </p:nvSpPr>
         <p:spPr>
-          <a:xfrm>
-            <a:off x="9792450" y="4440838"/>
+          <a:xfrm rot="18863058">
+            <a:off x="10022850" y="4094732"/>
             <a:ext cx="708660" cy="161583"/>
           </a:xfrm>
           <a:prstGeom prst="rect">
@@ -21780,7 +21786,7 @@
         </p:nvSpPr>
         <p:spPr>
           <a:xfrm>
-            <a:off x="10512540" y="4498374"/>
+            <a:off x="10618676" y="5015118"/>
             <a:ext cx="1188720" cy="457200"/>
           </a:xfrm>
           <a:prstGeom prst="roundRect">
@@ -21854,8 +21860,8 @@
         </p:nvCxnSpPr>
         <p:spPr>
           <a:xfrm flipH="1" flipV="1">
-            <a:off x="10721546" y="3934855"/>
-            <a:ext cx="385354" cy="563519"/>
+            <a:off x="10867752" y="3779122"/>
+            <a:ext cx="345284" cy="1235996"/>
           </a:xfrm>
           <a:prstGeom prst="line">
             <a:avLst/>
@@ -21936,7 +21942,7 @@
         </p:nvSpPr>
         <p:spPr>
           <a:xfrm>
-            <a:off x="7721443" y="3014870"/>
+            <a:off x="6995919" y="2594210"/>
             <a:ext cx="708660" cy="161583"/>
           </a:xfrm>
           <a:prstGeom prst="rect">
@@ -21981,8 +21987,8 @@
         </p:nvCxnSpPr>
         <p:spPr>
           <a:xfrm flipH="1">
-            <a:off x="8778446" y="2974374"/>
-            <a:ext cx="1257300" cy="502920"/>
+            <a:off x="8810352" y="2320428"/>
+            <a:ext cx="1705454" cy="1009236"/>
           </a:xfrm>
           <a:prstGeom prst="line">
             <a:avLst/>
@@ -22021,8 +22027,8 @@
           <p:nvPr/>
         </p:nvSpPr>
         <p:spPr>
-          <a:xfrm>
-            <a:off x="9039703" y="3320063"/>
+          <a:xfrm rot="20028826">
+            <a:off x="8747421" y="2959200"/>
             <a:ext cx="708660" cy="161583"/>
           </a:xfrm>
           <a:prstGeom prst="rect">
@@ -22063,7 +22069,7 @@
         </p:nvSpPr>
         <p:spPr>
           <a:xfrm>
-            <a:off x="10416201" y="3129563"/>
+            <a:off x="10757777" y="2841068"/>
             <a:ext cx="708660" cy="161583"/>
           </a:xfrm>
           <a:prstGeom prst="rect">
@@ -22103,8 +22109,8 @@
           <p:nvPr/>
         </p:nvSpPr>
         <p:spPr>
-          <a:xfrm>
-            <a:off x="9579090" y="3221935"/>
+          <a:xfrm rot="1424711">
+            <a:off x="10541998" y="4679592"/>
             <a:ext cx="708660" cy="161583"/>
           </a:xfrm>
           <a:prstGeom prst="rect">
@@ -22149,8 +22155,8 @@
         </p:nvCxnSpPr>
         <p:spPr>
           <a:xfrm>
-            <a:off x="7932626" y="3705894"/>
-            <a:ext cx="228600" cy="0"/>
+            <a:off x="7639120" y="3493384"/>
+            <a:ext cx="554012" cy="64880"/>
           </a:xfrm>
           <a:prstGeom prst="line">
             <a:avLst/>
@@ -22195,8 +22201,8 @@
         </p:nvCxnSpPr>
         <p:spPr>
           <a:xfrm>
-            <a:off x="7269686" y="3934494"/>
-            <a:ext cx="3837214" cy="563880"/>
+            <a:off x="6976180" y="3721984"/>
+            <a:ext cx="4236856" cy="1293134"/>
           </a:xfrm>
           <a:prstGeom prst="line">
             <a:avLst/>
@@ -22240,8 +22246,8 @@
         </p:nvCxnSpPr>
         <p:spPr>
           <a:xfrm>
-            <a:off x="8778446" y="3934494"/>
-            <a:ext cx="2328454" cy="563880"/>
+            <a:off x="8810352" y="3786864"/>
+            <a:ext cx="2402684" cy="1228254"/>
           </a:xfrm>
           <a:prstGeom prst="line">
             <a:avLst/>
@@ -22286,8 +22292,8 @@
         </p:nvCxnSpPr>
         <p:spPr>
           <a:xfrm flipH="1">
-            <a:off x="7292546" y="3934855"/>
-            <a:ext cx="3429000" cy="502559"/>
+            <a:off x="6899159" y="3779122"/>
+            <a:ext cx="3968593" cy="947852"/>
           </a:xfrm>
           <a:prstGeom prst="line">
             <a:avLst/>
@@ -22327,8 +22333,8 @@
           <p:nvPr/>
         </p:nvSpPr>
         <p:spPr>
-          <a:xfrm>
-            <a:off x="9774489" y="4038004"/>
+          <a:xfrm rot="20840578">
+            <a:off x="9489397" y="3846185"/>
             <a:ext cx="708660" cy="161583"/>
           </a:xfrm>
           <a:prstGeom prst="rect">
@@ -22373,8 +22379,8 @@
         </p:nvCxnSpPr>
         <p:spPr>
           <a:xfrm>
-            <a:off x="7269686" y="3934494"/>
-            <a:ext cx="891540" cy="731520"/>
+            <a:off x="6976180" y="3721984"/>
+            <a:ext cx="1414190" cy="1360217"/>
           </a:xfrm>
           <a:prstGeom prst="line">
             <a:avLst/>
@@ -22414,8 +22420,8 @@
           <p:nvPr/>
         </p:nvSpPr>
         <p:spPr>
-          <a:xfrm>
-            <a:off x="7477603" y="4120165"/>
+          <a:xfrm rot="2591742">
+            <a:off x="7280905" y="4128348"/>
             <a:ext cx="708660" cy="161583"/>
           </a:xfrm>
           <a:prstGeom prst="rect">
@@ -22455,8 +22461,8 @@
           <p:nvPr/>
         </p:nvSpPr>
         <p:spPr>
-          <a:xfrm rot="385312">
-            <a:off x="8918872" y="4081941"/>
+          <a:xfrm rot="1029337">
+            <a:off x="9122325" y="4311196"/>
             <a:ext cx="708660" cy="161583"/>
           </a:xfrm>
           <a:prstGeom prst="rect">
@@ -22629,8 +22635,8 @@
         </p:nvSpPr>
         <p:spPr>
           <a:xfrm>
-            <a:off x="8546580" y="1045399"/>
-            <a:ext cx="1965960" cy="665978"/>
+            <a:off x="8712632" y="917737"/>
+            <a:ext cx="1294399" cy="428677"/>
           </a:xfrm>
           <a:prstGeom prst="foldedCorner">
             <a:avLst/>
@@ -22682,6 +22688,129 @@
             <a:r>
               <a:rPr lang="en-IL" dirty="0"/>
               <a:t>Policy</a:t>
+            </a:r>
+          </a:p>
+        </p:txBody>
+      </p:sp>
+      <p:sp>
+        <p:nvSpPr>
+          <p:cNvPr id="105" name="TextBox 104">
+            <a:extLst>
+              <a:ext uri="{FF2B5EF4-FFF2-40B4-BE49-F238E27FC236}">
+                <a16:creationId xmlns:a16="http://schemas.microsoft.com/office/drawing/2014/main" id="{FF678327-D2F2-5202-0C69-0B64828323C0}"/>
+              </a:ext>
+            </a:extLst>
+          </p:cNvPr>
+          <p:cNvSpPr txBox="1"/>
+          <p:nvPr/>
+        </p:nvSpPr>
+        <p:spPr>
+          <a:xfrm rot="1059824">
+            <a:off x="9906396" y="2915838"/>
+            <a:ext cx="708660" cy="161583"/>
+          </a:xfrm>
+          <a:prstGeom prst="rect">
+            <a:avLst/>
+          </a:prstGeom>
+          <a:noFill/>
+        </p:spPr>
+        <p:txBody>
+          <a:bodyPr wrap="square" lIns="0" tIns="0" rIns="0" bIns="0" anchor="t">
+            <a:spAutoFit/>
+          </a:bodyPr>
+          <a:lstStyle/>
+          <a:p>
+            <a:pPr algn="l"/>
+            <a:r>
+              <a:rPr sz="1050" b="1" i="0" dirty="0">
+                <a:solidFill>
+                  <a:srgbClr val="C03B2E"/>
+                </a:solidFill>
+                <a:latin typeface="Calibri"/>
+              </a:rPr>
+              <a:t>✗ denied</a:t>
+            </a:r>
+          </a:p>
+        </p:txBody>
+      </p:sp>
+      <p:sp>
+        <p:nvSpPr>
+          <p:cNvPr id="106" name="TextBox 105">
+            <a:extLst>
+              <a:ext uri="{FF2B5EF4-FFF2-40B4-BE49-F238E27FC236}">
+                <a16:creationId xmlns:a16="http://schemas.microsoft.com/office/drawing/2014/main" id="{04121494-1B37-3CB6-1FA3-34FBA92797D0}"/>
+              </a:ext>
+            </a:extLst>
+          </p:cNvPr>
+          <p:cNvSpPr txBox="1"/>
+          <p:nvPr/>
+        </p:nvSpPr>
+        <p:spPr>
+          <a:xfrm rot="3339885">
+            <a:off x="8213524" y="2700601"/>
+            <a:ext cx="708660" cy="161583"/>
+          </a:xfrm>
+          <a:prstGeom prst="rect">
+            <a:avLst/>
+          </a:prstGeom>
+          <a:noFill/>
+        </p:spPr>
+        <p:txBody>
+          <a:bodyPr wrap="square" lIns="0" tIns="0" rIns="0" bIns="0" anchor="t">
+            <a:spAutoFit/>
+          </a:bodyPr>
+          <a:lstStyle/>
+          <a:p>
+            <a:pPr algn="l"/>
+            <a:r>
+              <a:rPr sz="1050" b="1" i="0" dirty="0">
+                <a:solidFill>
+                  <a:srgbClr val="C03B2E"/>
+                </a:solidFill>
+                <a:latin typeface="Calibri"/>
+              </a:rPr>
+              <a:t>✗ denied</a:t>
+            </a:r>
+          </a:p>
+        </p:txBody>
+      </p:sp>
+      <p:sp>
+        <p:nvSpPr>
+          <p:cNvPr id="107" name="TextBox 106">
+            <a:extLst>
+              <a:ext uri="{FF2B5EF4-FFF2-40B4-BE49-F238E27FC236}">
+                <a16:creationId xmlns:a16="http://schemas.microsoft.com/office/drawing/2014/main" id="{CED890E1-6E31-2EB0-C247-8D4EBF1B9B8A}"/>
+              </a:ext>
+            </a:extLst>
+          </p:cNvPr>
+          <p:cNvSpPr txBox="1"/>
+          <p:nvPr/>
+        </p:nvSpPr>
+        <p:spPr>
+          <a:xfrm rot="261937">
+            <a:off x="7649513" y="3340517"/>
+            <a:ext cx="708660" cy="161583"/>
+          </a:xfrm>
+          <a:prstGeom prst="rect">
+            <a:avLst/>
+          </a:prstGeom>
+          <a:noFill/>
+        </p:spPr>
+        <p:txBody>
+          <a:bodyPr wrap="square" lIns="0" tIns="0" rIns="0" bIns="0" anchor="t">
+            <a:spAutoFit/>
+          </a:bodyPr>
+          <a:lstStyle/>
+          <a:p>
+            <a:pPr algn="l"/>
+            <a:r>
+              <a:rPr sz="1050" b="1" i="0" dirty="0">
+                <a:solidFill>
+                  <a:srgbClr val="C03B2E"/>
+                </a:solidFill>
+                <a:latin typeface="Calibri"/>
+              </a:rPr>
+              <a:t>✗ denied</a:t>
             </a:r>
           </a:p>
         </p:txBody>

</xml_diff>